<commit_message>
fix: finalize submission deck and packaging notes
</commit_message>
<xml_diff>
--- a/submission_docs/Generative_Agents_课程答辩稿.pptx
+++ b/submission_docs/Generative_Agents_课程答辩稿.pptx
@@ -670,65 +670,6 @@
 </file>
 
 <file path=ppt/notesSlides/notesSlide25.xml><?xml version="1.0" encoding="utf-8"?>
-<p:notes xmlns:a="http://schemas.openxmlformats.org/drawingml/2006/main" xmlns:r="http://schemas.openxmlformats.org/officeDocument/2006/relationships" xmlns:p="http://schemas.openxmlformats.org/presentationml/2006/main">
-  <p:cSld>
-    <p:spTree>
-      <p:nvGrpSpPr>
-        <p:cNvPr id="1" name=""/>
-        <p:cNvGrpSpPr/>
-        <p:nvPr/>
-      </p:nvGrpSpPr>
-      <p:grpSpPr/>
-      <p:sp>
-        <p:nvSpPr>
-          <p:cNvPr id="18434" name="Rectangle 2"/>
-          <p:cNvSpPr>
-            <a:spLocks noGrp="1" noRot="1" noChangeAspect="1" noTextEdit="1"/>
-          </p:cNvSpPr>
-          <p:nvPr>
-            <p:ph type="sldImg"/>
-          </p:nvPr>
-        </p:nvSpPr>
-        <p:spPr>
-          <a:ln>
-            <a:miter lim="800000"/>
-          </a:ln>
-        </p:spPr>
-      </p:sp>
-      <p:sp>
-        <p:nvSpPr>
-          <p:cNvPr id="18435" name="Rectangle 3"/>
-          <p:cNvSpPr>
-            <a:spLocks noGrp="1"/>
-          </p:cNvSpPr>
-          <p:nvPr>
-            <p:ph type="body"/>
-          </p:nvPr>
-        </p:nvSpPr>
-        <p:spPr/>
-        <p:txBody>
-          <a:bodyPr wrap="square" lIns="91440" tIns="45720" rIns="91440" bIns="45720" anchor="t"/>
-          <a:p>
-            <a:pPr lvl="0" eaLnBrk="1" hangingPunct="1">
-              <a:spcBef>
-                <a:spcPct val="0"/>
-              </a:spcBef>
-            </a:pPr>
-            <a:endParaRPr lang="zh-CN" altLang="en-US" dirty="0">
-              <a:latin typeface="Arial" panose="020B0604020202020204" pitchFamily="34" charset="0"/>
-            </a:endParaRPr>
-          </a:p>
-        </p:txBody>
-      </p:sp>
-    </p:spTree>
-  </p:cSld>
-  <p:clrMapOvr>
-    <a:masterClrMapping/>
-  </p:clrMapOvr>
-</p:notes>
-</file>
-
-<file path=ppt/notesSlides/notesSlide26.xml><?xml version="1.0" encoding="utf-8"?>
 <p:notes xmlns:a="http://schemas.openxmlformats.org/drawingml/2006/main" xmlns:r="http://schemas.openxmlformats.org/officeDocument/2006/relationships" xmlns:p="http://schemas.openxmlformats.org/presentationml/2006/main">
   <p:cSld>
     <p:spTree>
@@ -3586,27 +3527,27 @@
 </file>
 
 <file path=ppt/slides/slide1.xml><?xml version="1.0" encoding="utf-8"?>
-<p:sld xmlns:a="http://schemas.openxmlformats.org/drawingml/2006/main" xmlns:p="http://schemas.openxmlformats.org/presentationml/2006/main" xmlns:r="http://schemas.openxmlformats.org/officeDocument/2006/relationships">
-  <p:cSld>
-    <p:spTree>
-      <p:nvGrpSpPr>
-        <p:cNvPr id="1" name=""/>
-        <p:cNvGrpSpPr/>
-        <p:nvPr/>
-      </p:nvGrpSpPr>
-      <p:grpSpPr/>
-      <p:sp>
-        <p:nvSpPr>
-          <p:cNvPr id="2" name="Title 1"/>
-          <p:cNvSpPr>
-            <a:spLocks noGrp="1"/>
-          </p:cNvSpPr>
-          <p:nvPr>
-            <p:ph type="ctrTitle"/>
-          </p:nvPr>
-        </p:nvSpPr>
-        <p:spPr/>
-        <p:txBody>
+<sld xmlns="http://schemas.openxmlformats.org/presentationml/2006/main" xmlns:a="http://schemas.openxmlformats.org/drawingml/2006/main">
+  <cSld>
+    <spTree>
+      <nvGrpSpPr>
+        <cNvPr id="1" name=""/>
+        <cNvGrpSpPr/>
+        <nvPr/>
+      </nvGrpSpPr>
+      <grpSpPr/>
+      <sp>
+        <nvSpPr>
+          <cNvPr id="2" name="Title 1"/>
+          <cNvSpPr>
+            <a:spLocks noGrp="1"/>
+          </cNvSpPr>
+          <nvPr>
+            <ph type="ctrTitle"/>
+          </nvPr>
+        </nvSpPr>
+        <spPr/>
+        <txBody>
           <a:bodyPr/>
           <a:lstStyle/>
           <a:p>
@@ -3621,20 +3562,20 @@
               <a:t>Generative Agents 论文复刻</a:t>
             </a:r>
           </a:p>
-        </p:txBody>
-      </p:sp>
-      <p:sp>
-        <p:nvSpPr>
-          <p:cNvPr id="3" name="Subtitle 2"/>
-          <p:cNvSpPr>
-            <a:spLocks noGrp="1"/>
-          </p:cNvSpPr>
-          <p:nvPr>
-            <p:ph type="subTitle" idx="1"/>
-          </p:nvPr>
-        </p:nvSpPr>
-        <p:spPr/>
-        <p:txBody>
+        </txBody>
+      </sp>
+      <sp>
+        <nvSpPr>
+          <cNvPr id="3" name="Subtitle 2"/>
+          <cNvSpPr>
+            <a:spLocks noGrp="1"/>
+          </cNvSpPr>
+          <nvPr>
+            <ph type="subTitle" idx="1"/>
+          </nvPr>
+        </nvSpPr>
+        <spPr/>
+        <txBody>
           <a:bodyPr/>
           <a:lstStyle/>
           <a:p>
@@ -3670,17 +3611,17 @@
                 </a:solidFill>
                 <a:latin typeface="Microsoft YaHei"/>
               </a:rPr>
-              <a:t>组员：待填写</a:t>
-            </a:r>
-          </a:p>
-        </p:txBody>
-      </p:sp>
-    </p:spTree>
-  </p:cSld>
-  <p:clrMapOvr>
+              <a:t/>
+            </a:r>
+          </a:p>
+        </txBody>
+      </sp>
+    </spTree>
+  </cSld>
+  <clrMapOvr>
     <a:masterClrMapping/>
-  </p:clrMapOvr>
-</p:sld>
+  </clrMapOvr>
+</sld>
 </file>
 
 <file path=ppt/slides/slide10.xml><?xml version="1.0" encoding="utf-8"?>
@@ -6030,724 +5971,6 @@
               </a:rPr>
               <a:t>谢谢老师。</a:t>
             </a:r>
-          </a:p>
-        </p:txBody>
-      </p:sp>
-    </p:spTree>
-  </p:cSld>
-  <p:clrMapOvr>
-    <a:masterClrMapping/>
-  </p:clrMapOvr>
-</p:sld>
-</file>
-
-<file path=ppt/slides/slide26.xml><?xml version="1.0" encoding="utf-8"?>
-<p:sld xmlns:a="http://schemas.openxmlformats.org/drawingml/2006/main" xmlns:r="http://schemas.openxmlformats.org/officeDocument/2006/relationships" xmlns:p="http://schemas.openxmlformats.org/presentationml/2006/main">
-  <p:cSld>
-    <p:spTree>
-      <p:nvGrpSpPr>
-        <p:cNvPr id="1" name=""/>
-        <p:cNvGrpSpPr/>
-        <p:nvPr/>
-      </p:nvGrpSpPr>
-      <p:grpSpPr/>
-      <p:cxnSp>
-        <p:nvCxnSpPr>
-          <p:cNvPr id="5" name="直接连接符 4"/>
-          <p:cNvCxnSpPr/>
-          <p:nvPr/>
-        </p:nvCxnSpPr>
-        <p:spPr>
-          <a:xfrm>
-            <a:off x="137584" y="897467"/>
-            <a:ext cx="11616267" cy="0"/>
-          </a:xfrm>
-          <a:prstGeom prst="line">
-            <a:avLst/>
-          </a:prstGeom>
-          <a:ln w="34925" cmpd="sng">
-            <a:solidFill>
-              <a:schemeClr val="accent6"/>
-            </a:solidFill>
-          </a:ln>
-        </p:spPr>
-        <p:style>
-          <a:lnRef idx="1">
-            <a:schemeClr val="accent1"/>
-          </a:lnRef>
-          <a:fillRef idx="0">
-            <a:schemeClr val="accent1"/>
-          </a:fillRef>
-          <a:effectRef idx="0">
-            <a:schemeClr val="accent1"/>
-          </a:effectRef>
-          <a:fontRef idx="minor">
-            <a:schemeClr val="tx1"/>
-          </a:fontRef>
-        </p:style>
-      </p:cxnSp>
-      <p:sp>
-        <p:nvSpPr>
-          <p:cNvPr id="3" name="标题 1"/>
-          <p:cNvSpPr>
-            <a:spLocks noGrp="1"/>
-          </p:cNvSpPr>
-          <p:nvPr/>
-        </p:nvSpPr>
-        <p:spPr>
-          <a:xfrm>
-            <a:off x="463137" y="174094"/>
-            <a:ext cx="10187929" cy="736490"/>
-          </a:xfrm>
-          <a:prstGeom prst="rect">
-            <a:avLst/>
-          </a:prstGeom>
-        </p:spPr>
-        <p:txBody>
-          <a:bodyPr vert="horz" lIns="91440" tIns="45720" rIns="91440" bIns="45720" rtlCol="0" anchor="ctr">
-            <a:normAutofit/>
-          </a:bodyPr>
-          <a:lstStyle>
-            <a:lvl1pPr algn="l" defTabSz="914400" rtl="0" eaLnBrk="1" latinLnBrk="0" hangingPunct="1">
-              <a:lnSpc>
-                <a:spcPct val="90000"/>
-              </a:lnSpc>
-              <a:spcBef>
-                <a:spcPct val="0"/>
-              </a:spcBef>
-              <a:buNone/>
-              <a:defRPr sz="4000" b="1" kern="1200" baseline="0">
-                <a:solidFill>
-                  <a:schemeClr val="tx1"/>
-                </a:solidFill>
-                <a:latin typeface="微软雅黑" panose="020B0503020204020204" charset="-122"/>
-                <a:ea typeface="微软雅黑" panose="020B0503020204020204" charset="-122"/>
-                <a:cs typeface="+mj-cs"/>
-              </a:defRPr>
-            </a:lvl1pPr>
-          </a:lstStyle>
-          <a:p>
-            <a:r>
-              <a:rPr lang="zh-CN" altLang="en-US" dirty="0">
-                <a:solidFill>
-                  <a:schemeClr val="tx1"/>
-                </a:solidFill>
-                <a:latin typeface="微软雅黑" charset="0"/>
-                <a:ea typeface="微软雅黑" charset="0"/>
-                <a:sym typeface="+mn-ea"/>
-              </a:rPr>
-              <a:t>C</a:t>
-            </a:r>
-            <a:r>
-              <a:rPr lang="en-US" altLang="zh-CN" dirty="0">
-                <a:solidFill>
-                  <a:schemeClr val="tx1"/>
-                </a:solidFill>
-                <a:latin typeface="微软雅黑" charset="0"/>
-                <a:ea typeface="微软雅黑" charset="0"/>
-                <a:sym typeface="+mn-ea"/>
-              </a:rPr>
-              <a:t>oT </a:t>
-            </a:r>
-            <a:r>
-              <a:rPr lang="zh-CN" altLang="en-US" dirty="0">
-                <a:solidFill>
-                  <a:schemeClr val="tx1"/>
-                </a:solidFill>
-                <a:latin typeface="微软雅黑" charset="0"/>
-                <a:ea typeface="微软雅黑" charset="0"/>
-                <a:sym typeface="+mn-ea"/>
-              </a:rPr>
-              <a:t>思维链推理</a:t>
-            </a:r>
-            <a:endParaRPr lang="zh-CN" altLang="en-US">
-              <a:latin typeface="微软雅黑" charset="0"/>
-              <a:ea typeface="微软雅黑" charset="0"/>
-              <a:sym typeface="+mn-ea"/>
-            </a:endParaRPr>
-          </a:p>
-        </p:txBody>
-      </p:sp>
-      <p:pic>
-        <p:nvPicPr>
-          <p:cNvPr id="2" name="图片 1" descr="post_object_image_3194464553"/>
-          <p:cNvPicPr>
-            <a:picLocks noChangeAspect="1"/>
-          </p:cNvPicPr>
-          <p:nvPr/>
-        </p:nvPicPr>
-        <p:blipFill>
-          <a:blip r:embed="rId1"/>
-          <a:stretch>
-            <a:fillRect/>
-          </a:stretch>
-        </p:blipFill>
-        <p:spPr>
-          <a:xfrm>
-            <a:off x="1828824" y="910632"/>
-            <a:ext cx="8534400" cy="3810000"/>
-          </a:xfrm>
-          <a:prstGeom prst="rect">
-            <a:avLst/>
-          </a:prstGeom>
-        </p:spPr>
-      </p:pic>
-      <p:sp>
-        <p:nvSpPr>
-          <p:cNvPr id="6" name="文本框 5"/>
-          <p:cNvSpPr txBox="1"/>
-          <p:nvPr userDrawn="1"/>
-        </p:nvSpPr>
-        <p:spPr>
-          <a:xfrm>
-            <a:off x="450684" y="4956514"/>
-            <a:ext cx="11290680" cy="1143969"/>
-          </a:xfrm>
-          <a:prstGeom prst="rect">
-            <a:avLst/>
-          </a:prstGeom>
-        </p:spPr>
-        <p:txBody>
-          <a:bodyPr wrap="square" rtlCol="0">
-            <a:noAutofit/>
-          </a:bodyPr>
-          <a:p>
-            <a:pPr algn="ctr"/>
-            <a:r>
-              <a:rPr lang="zh-CN" altLang="en-US" sz="3000">
-                <a:latin typeface="Times New Roman" panose="02020603050405020304" pitchFamily="18" charset="0"/>
-                <a:ea typeface="Times New Roman" panose="02020603050405020304" pitchFamily="18" charset="0"/>
-                <a:cs typeface="Times New Roman" panose="02020603050405020304" pitchFamily="18" charset="0"/>
-              </a:rPr>
-              <a:t>通过</a:t>
-            </a:r>
-            <a:r>
-              <a:rPr lang="zh-CN" altLang="en-US" sz="3000">
-                <a:solidFill>
-                  <a:schemeClr val="tx1"/>
-                </a:solidFill>
-                <a:latin typeface="Times New Roman" panose="02020603050405020304" pitchFamily="18" charset="0"/>
-                <a:ea typeface="Times New Roman" panose="02020603050405020304" pitchFamily="18" charset="0"/>
-                <a:cs typeface="Times New Roman" panose="02020603050405020304" pitchFamily="18" charset="0"/>
-              </a:rPr>
-              <a:t>思维链</a:t>
-            </a:r>
-            <a:r>
-              <a:rPr lang="zh-CN" altLang="en-US" sz="3000">
-                <a:latin typeface="Times New Roman" panose="02020603050405020304" pitchFamily="18" charset="0"/>
-                <a:ea typeface="Times New Roman" panose="02020603050405020304" pitchFamily="18" charset="0"/>
-                <a:cs typeface="Times New Roman" panose="02020603050405020304" pitchFamily="18" charset="0"/>
-              </a:rPr>
-              <a:t>在</a:t>
-            </a:r>
-            <a:r>
-              <a:rPr lang="en-US" altLang="zh-CN" sz="3000">
-                <a:latin typeface="Times New Roman" panose="02020603050405020304" pitchFamily="18" charset="0"/>
-                <a:ea typeface="Times New Roman" panose="02020603050405020304" pitchFamily="18" charset="0"/>
-                <a:cs typeface="Times New Roman" panose="02020603050405020304" pitchFamily="18" charset="0"/>
-              </a:rPr>
-              <a:t> GSM8K </a:t>
-            </a:r>
-            <a:r>
-              <a:rPr lang="zh-CN" altLang="en-US" sz="3000">
-                <a:latin typeface="Times New Roman" panose="02020603050405020304" pitchFamily="18" charset="0"/>
-                <a:ea typeface="Times New Roman" panose="02020603050405020304" pitchFamily="18" charset="0"/>
-                <a:cs typeface="Times New Roman" panose="02020603050405020304" pitchFamily="18" charset="0"/>
-              </a:rPr>
-              <a:t>数据集上</a:t>
-            </a:r>
-            <a:endParaRPr lang="zh-CN" altLang="en-US" sz="3000">
-              <a:latin typeface="Times New Roman" panose="02020603050405020304" pitchFamily="18" charset="0"/>
-              <a:ea typeface="Times New Roman" panose="02020603050405020304" pitchFamily="18" charset="0"/>
-              <a:cs typeface="Times New Roman" panose="02020603050405020304" pitchFamily="18" charset="0"/>
-            </a:endParaRPr>
-          </a:p>
-          <a:p>
-            <a:pPr algn="ctr"/>
-            <a:r>
-              <a:rPr lang="zh-CN" altLang="en-US" sz="3000">
-                <a:latin typeface="Times New Roman" panose="02020603050405020304" pitchFamily="18" charset="0"/>
-                <a:ea typeface="Times New Roman" panose="02020603050405020304" pitchFamily="18" charset="0"/>
-                <a:cs typeface="Times New Roman" panose="02020603050405020304" pitchFamily="18" charset="0"/>
-              </a:rPr>
-              <a:t>测试</a:t>
-            </a:r>
-            <a:r>
-              <a:rPr lang="en-US" altLang="zh-CN" sz="3000">
-                <a:latin typeface="Times New Roman" panose="02020603050405020304" pitchFamily="18" charset="0"/>
-                <a:ea typeface="Times New Roman" panose="02020603050405020304" pitchFamily="18" charset="0"/>
-                <a:cs typeface="Times New Roman" panose="02020603050405020304" pitchFamily="18" charset="0"/>
-              </a:rPr>
-              <a:t> ChatGPT </a:t>
-            </a:r>
-            <a:r>
-              <a:rPr lang="zh-CN" altLang="en-US" sz="3000">
-                <a:latin typeface="Times New Roman" panose="02020603050405020304" pitchFamily="18" charset="0"/>
-                <a:ea typeface="Times New Roman" panose="02020603050405020304" pitchFamily="18" charset="0"/>
-                <a:cs typeface="Times New Roman" panose="02020603050405020304" pitchFamily="18" charset="0"/>
-              </a:rPr>
-              <a:t>的数学推理能力</a:t>
-            </a:r>
-            <a:endParaRPr lang="zh-CN" altLang="en-US" sz="3000">
-              <a:latin typeface="Times New Roman" panose="02020603050405020304" pitchFamily="18" charset="0"/>
-              <a:ea typeface="Times New Roman" panose="02020603050405020304" pitchFamily="18" charset="0"/>
-              <a:cs typeface="Times New Roman" panose="02020603050405020304" pitchFamily="18" charset="0"/>
-            </a:endParaRPr>
-          </a:p>
-        </p:txBody>
-      </p:sp>
-    </p:spTree>
-  </p:cSld>
-  <p:clrMapOvr>
-    <a:masterClrMapping/>
-  </p:clrMapOvr>
-</p:sld>
-</file>
-
-<file path=ppt/slides/slide27.xml><?xml version="1.0" encoding="utf-8"?>
-<p:sld xmlns:a="http://schemas.openxmlformats.org/drawingml/2006/main" xmlns:r="http://schemas.openxmlformats.org/officeDocument/2006/relationships" xmlns:p="http://schemas.openxmlformats.org/presentationml/2006/main">
-  <p:cSld>
-    <p:spTree>
-      <p:nvGrpSpPr>
-        <p:cNvPr id="1" name=""/>
-        <p:cNvGrpSpPr/>
-        <p:nvPr/>
-      </p:nvGrpSpPr>
-      <p:grpSpPr/>
-      <p:cxnSp>
-        <p:nvCxnSpPr>
-          <p:cNvPr id="5" name="直接连接符 4"/>
-          <p:cNvCxnSpPr/>
-          <p:nvPr/>
-        </p:nvCxnSpPr>
-        <p:spPr>
-          <a:xfrm>
-            <a:off x="137584" y="897467"/>
-            <a:ext cx="11616267" cy="0"/>
-          </a:xfrm>
-          <a:prstGeom prst="line">
-            <a:avLst/>
-          </a:prstGeom>
-          <a:ln w="34925" cmpd="sng">
-            <a:solidFill>
-              <a:schemeClr val="accent6"/>
-            </a:solidFill>
-          </a:ln>
-        </p:spPr>
-        <p:style>
-          <a:lnRef idx="1">
-            <a:schemeClr val="accent1"/>
-          </a:lnRef>
-          <a:fillRef idx="0">
-            <a:schemeClr val="accent1"/>
-          </a:fillRef>
-          <a:effectRef idx="0">
-            <a:schemeClr val="accent1"/>
-          </a:effectRef>
-          <a:fontRef idx="minor">
-            <a:schemeClr val="tx1"/>
-          </a:fontRef>
-        </p:style>
-      </p:cxnSp>
-      <p:sp>
-        <p:nvSpPr>
-          <p:cNvPr id="3" name="标题 1"/>
-          <p:cNvSpPr>
-            <a:spLocks noGrp="1"/>
-          </p:cNvSpPr>
-          <p:nvPr/>
-        </p:nvSpPr>
-        <p:spPr>
-          <a:xfrm>
-            <a:off x="463137" y="174094"/>
-            <a:ext cx="10187929" cy="736490"/>
-          </a:xfrm>
-          <a:prstGeom prst="rect">
-            <a:avLst/>
-          </a:prstGeom>
-        </p:spPr>
-        <p:txBody>
-          <a:bodyPr vert="horz" lIns="91440" tIns="45720" rIns="91440" bIns="45720" rtlCol="0" anchor="ctr">
-            <a:normAutofit/>
-          </a:bodyPr>
-          <a:lstStyle>
-            <a:lvl1pPr algn="l" defTabSz="914400" rtl="0" eaLnBrk="1" latinLnBrk="0" hangingPunct="1">
-              <a:lnSpc>
-                <a:spcPct val="90000"/>
-              </a:lnSpc>
-              <a:spcBef>
-                <a:spcPct val="0"/>
-              </a:spcBef>
-              <a:buNone/>
-              <a:defRPr sz="4000" b="1" kern="1200" baseline="0">
-                <a:solidFill>
-                  <a:schemeClr val="tx1"/>
-                </a:solidFill>
-                <a:latin typeface="微软雅黑" panose="020B0503020204020204" charset="-122"/>
-                <a:ea typeface="微软雅黑" panose="020B0503020204020204" charset="-122"/>
-                <a:cs typeface="+mj-cs"/>
-              </a:defRPr>
-            </a:lvl1pPr>
-          </a:lstStyle>
-          <a:p>
-            <a:r>
-              <a:rPr lang="zh-CN" altLang="en-US" dirty="0">
-                <a:solidFill>
-                  <a:schemeClr val="tx1"/>
-                </a:solidFill>
-                <a:latin typeface="微软雅黑" charset="0"/>
-                <a:ea typeface="微软雅黑" charset="0"/>
-                <a:sym typeface="+mn-ea"/>
-              </a:rPr>
-              <a:t>Q</a:t>
-            </a:r>
-            <a:r>
-              <a:rPr lang="en-US" altLang="zh-CN" dirty="0">
-                <a:solidFill>
-                  <a:schemeClr val="tx1"/>
-                </a:solidFill>
-                <a:latin typeface="微软雅黑" charset="0"/>
-                <a:ea typeface="微软雅黑" charset="0"/>
-                <a:sym typeface="+mn-ea"/>
-              </a:rPr>
-              <a:t>WEN</a:t>
-            </a:r>
-            <a:r>
-              <a:rPr lang="zh-CN" altLang="en-US" dirty="0">
-                <a:solidFill>
-                  <a:schemeClr val="tx1"/>
-                </a:solidFill>
-                <a:latin typeface="微软雅黑" charset="0"/>
-                <a:ea typeface="微软雅黑" charset="0"/>
-                <a:sym typeface="+mn-ea"/>
-              </a:rPr>
-              <a:t>-</a:t>
-            </a:r>
-            <a:r>
-              <a:rPr lang="en-US" altLang="zh-CN" dirty="0">
-                <a:solidFill>
-                  <a:schemeClr val="tx1"/>
-                </a:solidFill>
-                <a:latin typeface="微软雅黑" charset="0"/>
-                <a:ea typeface="微软雅黑" charset="0"/>
-                <a:sym typeface="+mn-ea"/>
-              </a:rPr>
-              <a:t>plus</a:t>
-            </a:r>
-            <a:endParaRPr lang="zh-CN" altLang="en-US">
-              <a:latin typeface="微软雅黑" charset="0"/>
-              <a:ea typeface="微软雅黑" charset="0"/>
-              <a:sym typeface="+mn-ea"/>
-            </a:endParaRPr>
-          </a:p>
-        </p:txBody>
-      </p:sp>
-      <p:pic>
-        <p:nvPicPr>
-          <p:cNvPr id="4" name="图片 3" descr="post_object_image_1688790412"/>
-          <p:cNvPicPr>
-            <a:picLocks noChangeAspect="1"/>
-          </p:cNvPicPr>
-          <p:nvPr/>
-        </p:nvPicPr>
-        <p:blipFill>
-          <a:blip r:embed="rId1"/>
-          <a:stretch>
-            <a:fillRect/>
-          </a:stretch>
-        </p:blipFill>
-        <p:spPr>
-          <a:xfrm>
-            <a:off x="573372" y="1176846"/>
-            <a:ext cx="6629851" cy="5050762"/>
-          </a:xfrm>
-          <a:prstGeom prst="rect">
-            <a:avLst/>
-          </a:prstGeom>
-        </p:spPr>
-      </p:pic>
-      <p:sp>
-        <p:nvSpPr>
-          <p:cNvPr id="7" name="文本框 6"/>
-          <p:cNvSpPr txBox="1"/>
-          <p:nvPr userDrawn="1"/>
-        </p:nvSpPr>
-        <p:spPr>
-          <a:xfrm>
-            <a:off x="7741514" y="1299068"/>
-            <a:ext cx="3999850" cy="4801415"/>
-          </a:xfrm>
-          <a:prstGeom prst="rect">
-            <a:avLst/>
-          </a:prstGeom>
-        </p:spPr>
-        <p:txBody>
-          <a:bodyPr wrap="square" rtlCol="0">
-            <a:noAutofit/>
-          </a:bodyPr>
-          <a:p>
-            <a:pPr algn="l"/>
-            <a:r>
-              <a:rPr lang="zh-CN" altLang="en-US" sz="3000">
-                <a:latin typeface="Times New Roman" panose="02020603050405020304" pitchFamily="18" charset="0"/>
-                <a:ea typeface="Times New Roman" panose="02020603050405020304" pitchFamily="18" charset="0"/>
-                <a:cs typeface="Times New Roman" panose="02020603050405020304" pitchFamily="18" charset="0"/>
-              </a:rPr>
-              <a:t>在</a:t>
-            </a:r>
-            <a:r>
-              <a:rPr lang="en-US" altLang="zh-CN" sz="3000">
-                <a:latin typeface="Times New Roman" panose="02020603050405020304" pitchFamily="18" charset="0"/>
-                <a:ea typeface="Times New Roman" panose="02020603050405020304" pitchFamily="18" charset="0"/>
-                <a:cs typeface="Times New Roman" panose="02020603050405020304" pitchFamily="18" charset="0"/>
-              </a:rPr>
-              <a:t> </a:t>
-            </a:r>
-            <a:r>
-              <a:rPr lang="en-US" altLang="zh-CN" sz="3000">
-                <a:solidFill>
-                  <a:srgbClr val="FF0000"/>
-                </a:solidFill>
-                <a:latin typeface="Times New Roman" panose="02020603050405020304" pitchFamily="18" charset="0"/>
-                <a:ea typeface="Times New Roman" panose="02020603050405020304" pitchFamily="18" charset="0"/>
-                <a:cs typeface="Times New Roman" panose="02020603050405020304" pitchFamily="18" charset="0"/>
-              </a:rPr>
-              <a:t>Qwen-Plus</a:t>
-            </a:r>
-            <a:r>
-              <a:rPr lang="en-US" altLang="zh-CN" sz="3000">
-                <a:latin typeface="Times New Roman" panose="02020603050405020304" pitchFamily="18" charset="0"/>
-                <a:ea typeface="Times New Roman" panose="02020603050405020304" pitchFamily="18" charset="0"/>
-                <a:cs typeface="Times New Roman" panose="02020603050405020304" pitchFamily="18" charset="0"/>
-              </a:rPr>
-              <a:t> </a:t>
-            </a:r>
-            <a:r>
-              <a:rPr lang="zh-CN" altLang="en-US" sz="3000">
-                <a:latin typeface="Times New Roman" panose="02020603050405020304" pitchFamily="18" charset="0"/>
-                <a:ea typeface="Times New Roman" panose="02020603050405020304" pitchFamily="18" charset="0"/>
-                <a:cs typeface="Times New Roman" panose="02020603050405020304" pitchFamily="18" charset="0"/>
-              </a:rPr>
-              <a:t>模型上进行</a:t>
-            </a:r>
-            <a:r>
-              <a:rPr lang="en-US" altLang="zh-CN" sz="3000">
-                <a:latin typeface="Times New Roman" panose="02020603050405020304" pitchFamily="18" charset="0"/>
-                <a:ea typeface="Times New Roman" panose="02020603050405020304" pitchFamily="18" charset="0"/>
-                <a:cs typeface="Times New Roman" panose="02020603050405020304" pitchFamily="18" charset="0"/>
-              </a:rPr>
-              <a:t> </a:t>
-            </a:r>
-            <a:r>
-              <a:rPr lang="en-US" altLang="zh-CN" sz="3000">
-                <a:solidFill>
-                  <a:srgbClr val="FF0000"/>
-                </a:solidFill>
-                <a:latin typeface="Times New Roman" panose="02020603050405020304" pitchFamily="18" charset="0"/>
-                <a:ea typeface="Times New Roman" panose="02020603050405020304" pitchFamily="18" charset="0"/>
-                <a:cs typeface="Times New Roman" panose="02020603050405020304" pitchFamily="18" charset="0"/>
-              </a:rPr>
-              <a:t>GSM8K</a:t>
-            </a:r>
-            <a:r>
-              <a:rPr lang="en-US" altLang="zh-CN" sz="3000">
-                <a:latin typeface="Times New Roman" panose="02020603050405020304" pitchFamily="18" charset="0"/>
-                <a:ea typeface="Times New Roman" panose="02020603050405020304" pitchFamily="18" charset="0"/>
-                <a:cs typeface="Times New Roman" panose="02020603050405020304" pitchFamily="18" charset="0"/>
-              </a:rPr>
-              <a:t> </a:t>
-            </a:r>
-            <a:r>
-              <a:rPr lang="zh-CN" altLang="en-US" sz="3000">
-                <a:latin typeface="Times New Roman" panose="02020603050405020304" pitchFamily="18" charset="0"/>
-                <a:ea typeface="Times New Roman" panose="02020603050405020304" pitchFamily="18" charset="0"/>
-                <a:cs typeface="Times New Roman" panose="02020603050405020304" pitchFamily="18" charset="0"/>
-              </a:rPr>
-              <a:t>数据集的数学推理实验中，三种方法的表现如下：</a:t>
-            </a:r>
-            <a:r>
-              <a:rPr lang="en-US" altLang="zh-CN" sz="3000">
-                <a:solidFill>
-                  <a:srgbClr val="FF0000"/>
-                </a:solidFill>
-                <a:latin typeface="Times New Roman" panose="02020603050405020304" pitchFamily="18" charset="0"/>
-                <a:ea typeface="Times New Roman" panose="02020603050405020304" pitchFamily="18" charset="0"/>
-                <a:cs typeface="Times New Roman" panose="02020603050405020304" pitchFamily="18" charset="0"/>
-              </a:rPr>
-              <a:t>Zero-shot</a:t>
-            </a:r>
-            <a:r>
-              <a:rPr lang="en-US" altLang="zh-CN" sz="3000">
-                <a:latin typeface="Times New Roman" panose="02020603050405020304" pitchFamily="18" charset="0"/>
-                <a:ea typeface="Times New Roman" panose="02020603050405020304" pitchFamily="18" charset="0"/>
-                <a:cs typeface="Times New Roman" panose="02020603050405020304" pitchFamily="18" charset="0"/>
-              </a:rPr>
-              <a:t> </a:t>
-            </a:r>
-            <a:r>
-              <a:rPr lang="zh-CN" altLang="en-US" sz="3000">
-                <a:latin typeface="Times New Roman" panose="02020603050405020304" pitchFamily="18" charset="0"/>
-                <a:ea typeface="Times New Roman" panose="02020603050405020304" pitchFamily="18" charset="0"/>
-                <a:cs typeface="Times New Roman" panose="02020603050405020304" pitchFamily="18" charset="0"/>
-              </a:rPr>
-              <a:t>的正确率为</a:t>
-            </a:r>
-            <a:r>
-              <a:rPr lang="en-US" altLang="zh-CN" sz="3000">
-                <a:latin typeface="Times New Roman" panose="02020603050405020304" pitchFamily="18" charset="0"/>
-                <a:ea typeface="Times New Roman" panose="02020603050405020304" pitchFamily="18" charset="0"/>
-                <a:cs typeface="Times New Roman" panose="02020603050405020304" pitchFamily="18" charset="0"/>
-              </a:rPr>
-              <a:t> </a:t>
-            </a:r>
-            <a:r>
-              <a:rPr lang="en-US" altLang="zh-CN" sz="3000">
-                <a:solidFill>
-                  <a:srgbClr val="FF0000"/>
-                </a:solidFill>
-                <a:latin typeface="Times New Roman" panose="02020603050405020304" pitchFamily="18" charset="0"/>
-                <a:ea typeface="Times New Roman" panose="02020603050405020304" pitchFamily="18" charset="0"/>
-                <a:cs typeface="Times New Roman" panose="02020603050405020304" pitchFamily="18" charset="0"/>
-              </a:rPr>
-              <a:t>82.0%</a:t>
-            </a:r>
-            <a:r>
-              <a:rPr lang="zh-CN" altLang="en-US" sz="3000">
-                <a:latin typeface="Times New Roman" panose="02020603050405020304" pitchFamily="18" charset="0"/>
-                <a:ea typeface="Times New Roman" panose="02020603050405020304" pitchFamily="18" charset="0"/>
-                <a:cs typeface="Times New Roman" panose="02020603050405020304" pitchFamily="18" charset="0"/>
-              </a:rPr>
-              <a:t>，</a:t>
-            </a:r>
-            <a:r>
-              <a:rPr lang="en-US" altLang="zh-CN" sz="3000">
-                <a:solidFill>
-                  <a:srgbClr val="FF0000"/>
-                </a:solidFill>
-                <a:latin typeface="Times New Roman" panose="02020603050405020304" pitchFamily="18" charset="0"/>
-                <a:ea typeface="Times New Roman" panose="02020603050405020304" pitchFamily="18" charset="0"/>
-                <a:cs typeface="Times New Roman" panose="02020603050405020304" pitchFamily="18" charset="0"/>
-              </a:rPr>
-              <a:t>Few-shot</a:t>
-            </a:r>
-            <a:r>
-              <a:rPr lang="en-US" altLang="zh-CN" sz="3000">
-                <a:latin typeface="Times New Roman" panose="02020603050405020304" pitchFamily="18" charset="0"/>
-                <a:ea typeface="Times New Roman" panose="02020603050405020304" pitchFamily="18" charset="0"/>
-                <a:cs typeface="Times New Roman" panose="02020603050405020304" pitchFamily="18" charset="0"/>
-              </a:rPr>
-              <a:t> </a:t>
-            </a:r>
-            <a:r>
-              <a:rPr lang="zh-CN" altLang="en-US" sz="3000">
-                <a:latin typeface="Times New Roman" panose="02020603050405020304" pitchFamily="18" charset="0"/>
-                <a:ea typeface="Times New Roman" panose="02020603050405020304" pitchFamily="18" charset="0"/>
-                <a:cs typeface="Times New Roman" panose="02020603050405020304" pitchFamily="18" charset="0"/>
-              </a:rPr>
-              <a:t>的正确率达到</a:t>
-            </a:r>
-            <a:r>
-              <a:rPr lang="en-US" altLang="zh-CN" sz="3000">
-                <a:latin typeface="Times New Roman" panose="02020603050405020304" pitchFamily="18" charset="0"/>
-                <a:ea typeface="Times New Roman" panose="02020603050405020304" pitchFamily="18" charset="0"/>
-                <a:cs typeface="Times New Roman" panose="02020603050405020304" pitchFamily="18" charset="0"/>
-              </a:rPr>
-              <a:t> </a:t>
-            </a:r>
-            <a:r>
-              <a:rPr lang="en-US" altLang="zh-CN" sz="3000">
-                <a:solidFill>
-                  <a:srgbClr val="FF0000"/>
-                </a:solidFill>
-                <a:latin typeface="Times New Roman" panose="02020603050405020304" pitchFamily="18" charset="0"/>
-                <a:ea typeface="Times New Roman" panose="02020603050405020304" pitchFamily="18" charset="0"/>
-                <a:cs typeface="Times New Roman" panose="02020603050405020304" pitchFamily="18" charset="0"/>
-              </a:rPr>
-              <a:t>100.0%</a:t>
-            </a:r>
-            <a:r>
-              <a:rPr lang="zh-CN" altLang="en-US" sz="3000">
-                <a:latin typeface="Times New Roman" panose="02020603050405020304" pitchFamily="18" charset="0"/>
-                <a:ea typeface="Times New Roman" panose="02020603050405020304" pitchFamily="18" charset="0"/>
-                <a:cs typeface="Times New Roman" panose="02020603050405020304" pitchFamily="18" charset="0"/>
-              </a:rPr>
-              <a:t>，而</a:t>
-            </a:r>
-            <a:r>
-              <a:rPr lang="en-US" altLang="zh-CN" sz="3000">
-                <a:latin typeface="Times New Roman" panose="02020603050405020304" pitchFamily="18" charset="0"/>
-                <a:ea typeface="Times New Roman" panose="02020603050405020304" pitchFamily="18" charset="0"/>
-                <a:cs typeface="Times New Roman" panose="02020603050405020304" pitchFamily="18" charset="0"/>
-              </a:rPr>
-              <a:t> </a:t>
-            </a:r>
-            <a:r>
-              <a:rPr lang="en-US" altLang="zh-CN" sz="3000">
-                <a:solidFill>
-                  <a:srgbClr val="FF0000"/>
-                </a:solidFill>
-                <a:latin typeface="Times New Roman" panose="02020603050405020304" pitchFamily="18" charset="0"/>
-                <a:ea typeface="Times New Roman" panose="02020603050405020304" pitchFamily="18" charset="0"/>
-                <a:cs typeface="Times New Roman" panose="02020603050405020304" pitchFamily="18" charset="0"/>
-              </a:rPr>
-              <a:t>CoT</a:t>
-            </a:r>
-            <a:r>
-              <a:rPr lang="en-US" altLang="zh-CN" sz="3000">
-                <a:latin typeface="Times New Roman" panose="02020603050405020304" pitchFamily="18" charset="0"/>
-                <a:ea typeface="Times New Roman" panose="02020603050405020304" pitchFamily="18" charset="0"/>
-                <a:cs typeface="Times New Roman" panose="02020603050405020304" pitchFamily="18" charset="0"/>
-              </a:rPr>
-              <a:t> </a:t>
-            </a:r>
-            <a:r>
-              <a:rPr lang="zh-CN" altLang="en-US" sz="3000">
-                <a:latin typeface="Times New Roman" panose="02020603050405020304" pitchFamily="18" charset="0"/>
-                <a:ea typeface="Times New Roman" panose="02020603050405020304" pitchFamily="18" charset="0"/>
-                <a:cs typeface="Times New Roman" panose="02020603050405020304" pitchFamily="18" charset="0"/>
-              </a:rPr>
-              <a:t>的正确率为</a:t>
-            </a:r>
-            <a:r>
-              <a:rPr lang="en-US" altLang="zh-CN" sz="3000">
-                <a:latin typeface="Times New Roman" panose="02020603050405020304" pitchFamily="18" charset="0"/>
-                <a:ea typeface="Times New Roman" panose="02020603050405020304" pitchFamily="18" charset="0"/>
-                <a:cs typeface="Times New Roman" panose="02020603050405020304" pitchFamily="18" charset="0"/>
-              </a:rPr>
-              <a:t> </a:t>
-            </a:r>
-            <a:r>
-              <a:rPr lang="en-US" altLang="zh-CN" sz="3000">
-                <a:solidFill>
-                  <a:srgbClr val="FF0000"/>
-                </a:solidFill>
-                <a:latin typeface="Times New Roman" panose="02020603050405020304" pitchFamily="18" charset="0"/>
-                <a:ea typeface="Times New Roman" panose="02020603050405020304" pitchFamily="18" charset="0"/>
-                <a:cs typeface="Times New Roman" panose="02020603050405020304" pitchFamily="18" charset="0"/>
-              </a:rPr>
-              <a:t>98.0%</a:t>
-            </a:r>
-            <a:r>
-              <a:rPr lang="zh-CN" altLang="en-US" sz="3000">
-                <a:latin typeface="Times New Roman" panose="02020603050405020304" pitchFamily="18" charset="0"/>
-                <a:ea typeface="Times New Roman" panose="02020603050405020304" pitchFamily="18" charset="0"/>
-                <a:cs typeface="Times New Roman" panose="02020603050405020304" pitchFamily="18" charset="0"/>
-              </a:rPr>
-              <a:t>。</a:t>
-            </a:r>
-            <a:endParaRPr lang="zh-CN" altLang="en-US" sz="3000">
-              <a:latin typeface="Times New Roman" panose="02020603050405020304" pitchFamily="18" charset="0"/>
-              <a:ea typeface="Times New Roman" panose="02020603050405020304" pitchFamily="18" charset="0"/>
-              <a:cs typeface="Times New Roman" panose="02020603050405020304" pitchFamily="18" charset="0"/>
-            </a:endParaRPr>
-          </a:p>
-          <a:p>
-            <a:pPr algn="ctr"/>
-            <a:endParaRPr lang="zh-CN" altLang="en-US" sz="3000">
-              <a:latin typeface="Times New Roman" panose="02020603050405020304" pitchFamily="18" charset="0"/>
-              <a:ea typeface="Times New Roman" panose="02020603050405020304" pitchFamily="18" charset="0"/>
-              <a:cs typeface="Times New Roman" panose="02020603050405020304" pitchFamily="18" charset="0"/>
-            </a:endParaRPr>
           </a:p>
         </p:txBody>
       </p:sp>

</xml_diff>